<commit_message>
fix: US deck notes/demo and gate-style controls fail on any breach
- SR 26-02 monitoring and FCA Impact tolerance now list every category,
  so they fail whenever the ASR gate fails (were pass on a FAIL run).
- build_us_deck.py rewrites speaker notes, the slide-14 terminal
  (--regimes us output), roadmap and CI claims; shorter titles fit one line.
- Align SR 26-02 GenAI scope wording with REGULATORY_RESEARCH §4.5b.

Claude-Session: https://claude.ai/code/session_01SFk2HbrZdbJqAYQPg8mbYw
</commit_message>
<xml_diff>
--- a/docs/Safety_and_Trust_Engine_US.pptx
+++ b/docs/Safety_and_Trust_Engine_US.pptx
@@ -299,8 +299,7 @@
           <a:lstStyle/>
           <a:p>
             <a:r>
-              <a:rPr lang="en-US" dirty="0"/>
-              <a:t>Open with two rows of logos: top the three regulators (EU AI Act, DORA, FCA), bottom the three tools (garak, AgentDojo, PyRIT). Land the line: you're probably already doing the red-teaming, you're just not producing the evidence. This is the Phase 5 sequel to the four-phase app talk.</a:t>
+              <a:t>Open with two rows: top the US lenses (NIST AI RMF, federal MRM / SR 26-02), bottom the three tools (garak, AgentDojo, PyRIT). Land the line: you're probably already doing the red-teaming, you're just not producing exam-ready evidence. Same engine as the EU/UK talk, read through US lenses with --regimes us.</a:t>
             </a:r>
           </a:p>
         </p:txBody>
@@ -473,8 +472,7 @@
           <a:lstStyle/>
           <a:p>
             <a:r>
-              <a:rPr lang="en-US" dirty="0"/>
-              <a:t>Show a row from an FCA self-assessment next to the DEFAULT_TOLERANCES dict — same concept, one prose, one enforced. Override per run with --fail-under category=rate.</a:t>
+              <a:t>Show the DEFAULT_TOLERANCES dict next to the SR 26-02 monitoring control: same concept, one prose, one enforced. The monitoring control fails whenever any category breaches. Override per run with --fail-under; tune per use case and risk appetite.</a:t>
             </a:r>
           </a:p>
         </p:txBody>
@@ -560,8 +558,7 @@
           <a:lstStyle/>
           <a:p>
             <a:r>
-              <a:rPr lang="en-US" dirty="0"/>
-              <a:t>Show one Control literal and the not_evidenced branch. Then the payoff for Art. 55: the artifact this produces is the documentation the regulation asks for.</a:t>
+              <a:t>Show the US Control literal with binding='guidance' and the not_evidenced branch. A control you didn't test never renders as one you passed — exactly what a model-risk reviewer checks first.</a:t>
             </a:r>
           </a:p>
         </p:txBody>
@@ -734,8 +731,7 @@
           <a:lstStyle/>
           <a:p>
             <a:r>
-              <a:rPr lang="en-US" dirty="0"/>
-              <a:t>Let the non-zero exit land before explaining it. A failing demo is the point — the gate is doing its job. Then open the Markdown artifact: cat .safety_outputs/st-*.md. The arc: Phase 4 found a subtle failure by hand; Phase 5 catches it and documents it automatically.</a:t>
+              <a:t>Run it live: uv run safety-engine --demo --regimes us. Let the non-zero exit land before explaining it — a failing demo is the point. Then open runs/st-*.md: only NIST AI RMF and Federal MRM sections, each row with its binding. Optional: rerun with --regimes eu_uk,us to show one evidence set, two lenses. Red CI on demand: Actions → safety-trust → Run workflow (demo-gate).</a:t>
             </a:r>
           </a:p>
         </p:txBody>
@@ -821,8 +817,7 @@
           <a:lstStyle/>
           <a:p>
             <a:r>
-              <a:rPr lang="en-US" dirty="0"/>
-              <a:t>W&amp;B's point: a decision package, not a score. Our Markdown artifact is the lightweight version and doubles as an FCA self-assessment. Position Weave as the production upgrade path for the evidence layer.</a:t>
+              <a:t>A decision package, not a score. The Markdown artifact is the lightweight model-risk file: what was tested, against which tolerance, which controls failed, what to remediate. Position Weave as the production upgrade path for the evidence layer.</a:t>
             </a:r>
           </a:p>
         </p:txBody>
@@ -908,8 +903,7 @@
           <a:lstStyle/>
           <a:p>
             <a:r>
-              <a:rPr lang="en-US" dirty="0"/>
-              <a:t>Dev → Pre-deploy → Production is the W&amp;B three-stage view. We own the middle. The feedback loop and the Bedrock port are the concrete next steps.</a:t>
+              <a:t>Dev → Pre-deploy → Production is the W&amp;B three-stage view. We own the middle. NIST and MRM are already wired; next lenses are the taxonomies US security teams ask for — OWASP LLM Top 10 and MITRE ATLAS — plus MIT AI Risk.</a:t>
             </a:r>
           </a:p>
         </p:txBody>
@@ -995,8 +989,7 @@
           <a:lstStyle/>
           <a:p>
             <a:r>
-              <a:rPr lang="en-US" dirty="0"/>
-              <a:t>Close on takeaway 2: your regulator does not want your scan, they want your gate. Then Q&amp;A — keep to five minutes, offer to continue offline. Resources: the repo docs plus the W&amp;B e-book the governance framing came from.</a:t>
+              <a:t>Close on takeaway 2: your examiner does not want your scan, they want your gate — with honest binding. Then Q&amp;A, five minutes, offer to continue offline. Resources: README, docs/US_COMPLIANCE.md, REGULATORY_RESEARCH.md §4.5.</a:t>
             </a:r>
           </a:p>
         </p:txBody>
@@ -1082,8 +1075,7 @@
           <a:lstStyle/>
           <a:p>
             <a:r>
-              <a:rPr lang="en-US" dirty="0"/>
-              <a:t>DORA applicable Jan 2025; FCA transition closed Mar 2025; EU AI Act robustness/cybersecurity for high-risk on the same timeline. The shift is from running attacks to operating a control. Pause on 'you're just not producing the evidence.'</a:t>
+              <a:t>In the US there is no single statute that says red-team your LLM. There is a stack of expectations: NIST AI 600-1 (July 2024) puts red-teaming in pre-deploy MEASURE, and the April 2026 interagency MRM revision (SR 26-02 / OCC 2026-13) replaces SR 11-7. Say early: NIST is voluntary, MRM is supervisory, and SR 26-02 leaves GenAI/agentic AI outside formal scope, so examiners apply it by analogy.</a:t>
             </a:r>
           </a:p>
         </p:txBody>
@@ -1256,8 +1248,7 @@
           <a:lstStyle/>
           <a:p>
             <a:r>
-              <a:rPr lang="en-US" dirty="0"/>
-              <a:t>Art. 15(4) covers feedback loops; 15(5) is the cybersecurity/adversarial half. Art. 55 reaches systemic-risk GPAI from a second direction. Flag the word 'document' — it pays off on the artifact slide.</a:t>
+              <a:t>MEASURE 2.6 is misuse and abuse, MEASURE 2.7 is security and resilience — the subcategory red-teaming exercises most directly. AI 600-1 adds GenAI-specific risks incl. prompt injection. Say it plainly: binding = guidance; never say 'NIST certified'. Flag the word 'documented' — it pays off on the artifact slide.</a:t>
             </a:r>
           </a:p>
         </p:txBody>
@@ -1343,8 +1334,7 @@
           <a:lstStyle/>
           <a:p>
             <a:r>
-              <a:rPr lang="en-US" dirty="0"/>
-              <a:t>Be honest before the audience is: CI is continuous assurance between formal TLPT exercises. The third-party point is the one people forget — Bedrock is in scope.</a:t>
+              <a:t>Three MRM pillars: sound development, independent validation (effective challenge, outcomes analysis), governance. Adversarial testing is outcomes analysis; the CI gate is ongoing monitoring. Be honest before the audience is: continuous CI assurance is not a formal validation exercise, and a hosted model (OpenAI, Azure, Bedrock) is a third-party model that stays in scope.</a:t>
             </a:r>
           </a:p>
         </p:txBody>
@@ -1430,8 +1420,7 @@
           <a:lstStyle/>
           <a:p>
             <a:r>
-              <a:rPr lang="en-US" dirty="0"/>
-              <a:t>This is the conceptual bridge to the gate. Land the sentence 'impact tolerance is just a maximum attack-success rate' and the architecture feels inevitable.</a:t>
+              <a:t>The bridge to the gate. The model-risk file a validator asks for is exactly what each run writes: verdict, per-category ASR vs tolerance, per-control status with binding, remediation list. Land: a tolerance is just a maximum attack-success rate — the same mechanic the EU deck calls impact tolerance.</a:t>
             </a:r>
           </a:p>
         </p:txBody>
@@ -1517,8 +1506,7 @@
           <a:lstStyle/>
           <a:p>
             <a:r>
-              <a:rPr lang="en-US" dirty="0"/>
-              <a:t>W&amp;B's toolkit maps NIST AI RMF and EU AI Act onto a shared MIT-based risk taxonomy. Same idea here: one finding, many lenses. Our compliance.py encodes EU AI Act/DORA/FCA; NIST and MIT are the obvious extensions.</a:t>
+              <a:t>One finding, many lenses. The same prompt-injection hit lands on MEASURE 2.7 and, if you select it, on EU AI Act Art. 15(5). compliance.py encodes both packs; --regimes us for US-only, --regimes eu_uk,us when you serve both markets. MIT AI Risk stays on the roadmap.</a:t>
             </a:r>
           </a:p>
         </p:txBody>
@@ -7104,7 +7092,7 @@
                 <a:ea typeface="Courier New" pitchFamily="34" charset="-122"/>
                 <a:cs typeface="Courier New" pitchFamily="34" charset="-120"/>
               </a:rPr>
-              <a:t>$ uv run safety-engine --demo</a:t>
+              <a:t>$ uv run safety-engine --demo --regimes us</a:t>
             </a:r>
             <a:endParaRPr lang="en-US" sz="1150" dirty="0"/>
           </a:p>
@@ -7124,7 +7112,7 @@
                 <a:ea typeface="Courier New" pitchFamily="34" charset="-122"/>
                 <a:cs typeface="Courier New" pitchFamily="34" charset="-120"/>
               </a:rPr>
-              <a:t>  [garak    ] ran: 5 probes</a:t>
+              <a:t>  [garak|agentdojo|pyrit] ran: 13 probes</a:t>
             </a:r>
             <a:endParaRPr lang="en-US" sz="1150" dirty="0"/>
           </a:p>
@@ -7138,13 +7126,13 @@
             <a:r>
               <a:rPr lang="en-US" sz="1150" dirty="0">
                 <a:solidFill>
-                  <a:srgbClr val="9CC0B8"/>
+                  <a:srgbClr val="F08A82"/>
                 </a:solidFill>
                 <a:latin typeface="Courier New" pitchFamily="34" charset="0"/>
                 <a:ea typeface="Courier New" pitchFamily="34" charset="-122"/>
                 <a:cs typeface="Courier New" pitchFamily="34" charset="-120"/>
               </a:rPr>
-              <a:t>  [agentdojo] ran: 4 probes</a:t>
+              <a:t>  [FAIL] prompt_injection 15%  (tol 10%)</a:t>
             </a:r>
             <a:endParaRPr lang="en-US" sz="1150" dirty="0"/>
           </a:p>
@@ -7158,13 +7146,13 @@
             <a:r>
               <a:rPr lang="en-US" sz="1150" dirty="0">
                 <a:solidFill>
-                  <a:srgbClr val="9CC0B8"/>
+                  <a:srgbClr val="F08A82"/>
                 </a:solidFill>
                 <a:latin typeface="Courier New" pitchFamily="34" charset="0"/>
                 <a:ea typeface="Courier New" pitchFamily="34" charset="-122"/>
                 <a:cs typeface="Courier New" pitchFamily="34" charset="-120"/>
               </a:rPr>
-              <a:t>  [pyrit    ] ran: 4 probes</a:t>
+              <a:t>  [FAIL] tool_injection   13%  (tol 5%)</a:t>
             </a:r>
             <a:endParaRPr lang="en-US" sz="1150" dirty="0"/>
           </a:p>
@@ -7193,7 +7181,7 @@
                 <a:ea typeface="Courier New" pitchFamily="34" charset="-122"/>
                 <a:cs typeface="Courier New" pitchFamily="34" charset="-120"/>
               </a:rPr>
-              <a:t>Impact tolerance gate:</a:t>
+              <a:t>Regimes: us · 8 controls, 5 failing</a:t>
             </a:r>
             <a:endParaRPr lang="en-US" sz="1150" dirty="0"/>
           </a:p>
@@ -7207,13 +7195,13 @@
             <a:r>
               <a:rPr lang="en-US" sz="1150" dirty="0">
                 <a:solidFill>
-                  <a:srgbClr val="2E9A66"/>
+                  <a:srgbClr val="F08A82"/>
                 </a:solidFill>
                 <a:latin typeface="Courier New" pitchFamily="34" charset="0"/>
                 <a:ea typeface="Courier New" pitchFamily="34" charset="-122"/>
                 <a:cs typeface="Courier New" pitchFamily="34" charset="-120"/>
               </a:rPr>
-              <a:t>  [ok  ] data_leakage      5%  (tol 5%)</a:t>
+              <a:t>  FAIL NIST AI RMF MEASURE 2.6 / 2.7</a:t>
             </a:r>
             <a:endParaRPr lang="en-US" sz="1150" dirty="0"/>
           </a:p>
@@ -7227,13 +7215,13 @@
             <a:r>
               <a:rPr lang="en-US" sz="1150" dirty="0">
                 <a:solidFill>
-                  <a:srgbClr val="2E9A66"/>
+                  <a:srgbClr val="F08A82"/>
                 </a:solidFill>
                 <a:latin typeface="Courier New" pitchFamily="34" charset="0"/>
                 <a:ea typeface="Courier New" pitchFamily="34" charset="-122"/>
                 <a:cs typeface="Courier New" pitchFamily="34" charset="-120"/>
               </a:rPr>
-              <a:t>  [ok  ] jailbreak         5%  (tol 10%)</a:t>
+              <a:t>  FAIL NIST AI RMF AI 600-1</a:t>
             </a:r>
             <a:endParaRPr lang="en-US" sz="1150" dirty="0"/>
           </a:p>
@@ -7253,7 +7241,7 @@
                 <a:ea typeface="Courier New" pitchFamily="34" charset="-122"/>
                 <a:cs typeface="Courier New" pitchFamily="34" charset="-120"/>
               </a:rPr>
-              <a:t>  [FAIL] prompt_injection 15%  (tol 10%)</a:t>
+              <a:t>  FAIL Federal MRM SR 26-02 validation</a:t>
             </a:r>
             <a:endParaRPr lang="en-US" sz="1150" dirty="0"/>
           </a:p>
@@ -7273,7 +7261,7 @@
                 <a:ea typeface="Courier New" pitchFamily="34" charset="-122"/>
                 <a:cs typeface="Courier New" pitchFamily="34" charset="-120"/>
               </a:rPr>
-              <a:t>  [FAIL] tool_injection   13%  (tol 5%)</a:t>
+              <a:t>  FAIL Federal MRM SR 26-02 monitoring</a:t>
             </a:r>
             <a:endParaRPr lang="en-US" sz="1150" dirty="0"/>
           </a:p>
@@ -7394,7 +7382,7 @@
                 <a:ea typeface="Calibri" pitchFamily="34" charset="-122"/>
                 <a:cs typeface="Calibri" pitchFamily="34" charset="-120"/>
               </a:rPr>
-              <a:t>The failing category is prompt_injection — the same delayed-compliance case a human would surface only by hand: the agent refuses, then appends an override to a tool argument.</a:t>
+              <a:t>The failing category is prompt_injection — the agent refuses, then appends an override to a tool argument. The artifact names it under MEASURE 2.6–2.7, AI 600-1 and SR 26-02.</a:t>
             </a:r>
             <a:endParaRPr lang="en-US" sz="1200" dirty="0"/>
           </a:p>
@@ -9603,7 +9591,7 @@
                 <a:ea typeface="Calibri" pitchFamily="34" charset="-122"/>
                 <a:cs typeface="Calibri" pitchFamily="34" charset="-120"/>
               </a:rPr>
-              <a:t>Wire NIST AI RMF and MIT AI Risk categories into the mapper.</a:t>
+              <a:t>Map findings to MIT AI Risk, OWASP LLM Top 10 and MITRE ATLAS.</a:t>
             </a:r>
             <a:endParaRPr lang="en-US" sz="1050" dirty="0"/>
           </a:p>
@@ -12025,7 +12013,7 @@
                 <a:ea typeface="Calibri" pitchFamily="34" charset="-122"/>
                 <a:cs typeface="Calibri" pitchFamily="34" charset="-120"/>
               </a:rPr>
-              <a:t>Enforcing safety-gate blocks a PR on any tolerance breach; lint+test + nightly live. CI green.</a:t>
+              <a:t>lint+test and merge-demo are required checks on main; strict and live gates run on demand.</a:t>
             </a:r>
             <a:endParaRPr lang="en-US" sz="1200" dirty="0"/>
           </a:p>
@@ -12311,7 +12299,7 @@
                 <a:ea typeface="Cambria" pitchFamily="34" charset="-122"/>
                 <a:cs typeface="Cambria" pitchFamily="34" charset="-120"/>
               </a:rPr>
-              <a:t>Adversarial testing is now an exam-ready expectation</a:t>
+              <a:t>Adversarial testing is now an exam expectation</a:t>
             </a:r>
             <a:endParaRPr lang="en-US" sz="2700" dirty="0"/>
           </a:p>
@@ -12736,7 +12724,7 @@
                 <a:ea typeface="Cambria" pitchFamily="34" charset="-122"/>
                 <a:cs typeface="Cambria" pitchFamily="34" charset="-120"/>
               </a:rPr>
-              <a:t>MEASURE 2.6–2.7</a:t>
+              <a:t>MEASURE 2.7</a:t>
             </a:r>
             <a:endParaRPr lang="en-US" sz="2500" dirty="0"/>
           </a:p>
@@ -15639,7 +15627,7 @@
                 <a:ea typeface="Cambria" pitchFamily="34" charset="-122"/>
                 <a:cs typeface="Cambria" pitchFamily="34" charset="-120"/>
               </a:rPr>
-              <a:t>Federal MRM — documentation &amp; decision package</a:t>
+              <a:t>Federal MRM — the decision package</a:t>
             </a:r>
             <a:endParaRPr lang="en-US" sz="2700" dirty="0"/>
           </a:p>

</xml_diff>